<commit_message>
feat: add kototech-theme, a general-purpose ことテク slide theme
- New kototech-theme/ with a template PPTX (5 layouts, one sample slide each)
- Main green (accent1) 4D9622; footer left blank so the theme fits any event or sales deck
- ことテク logo placed in slide layouts (white on the cover band, green top-right on
  content/table/section, none on closing); PNG plus embedded SVG for high-res rendering
- Cover catch copy at 13pt, bottom-aligned with the logo
- build_kototech_pptx.py builds decks from md (reuses the hackathon builder's theme
  generation), supports `<!-- layout: section -->` and month-calendar tables, and verifies
  theme colors, logo placement and leftover {{...}}
- make_logo.py traces the logo source image into SVG/PNG in any color
- Acceptance tests and README

Co-Authored-By: Claude Opus 5.5 <noreply@anthropic.com>
Claude-Session: https://claude.ai/code/session_01M66qdQfBAyB1eMNb8z4rRo
</commit_message>
<xml_diff>
--- a/hackathon-2026/team-slide-template-kotonara.pptx
+++ b/hackathon-2026/team-slide-template-kotonara.pptx
@@ -3849,7 +3849,7 @@
           </a:lstStyle>
           <a:p>
             <a:pPr algn="r"/>
-            <a:fld id="{40D8A089-FDE1-42B5-92B3-D3C065A8F993}" type="slidenum">
+            <a:fld id="{9E442E19-F360-4315-BE1F-ABD75DDFD513}" type="slidenum">
               <a:rPr lang="ja-JP" smtClean="0"/>
               <a:t>2</a:t>
             </a:fld>
@@ -4096,7 +4096,7 @@
           </a:lstStyle>
           <a:p>
             <a:pPr algn="r"/>
-            <a:fld id="{39F7A8FA-FDC9-488F-9AD8-B61132AE6A61}" type="slidenum">
+            <a:fld id="{B2264A87-3A8D-4D11-9D4C-DB76AC793911}" type="slidenum">
               <a:rPr lang="ja-JP" smtClean="0"/>
               <a:t>2</a:t>
             </a:fld>
@@ -4354,7 +4354,7 @@
           </a:lstStyle>
           <a:p>
             <a:pPr algn="r"/>
-            <a:fld id="{2EFCE54B-6231-45FB-B5F4-AFFD17C749CD}" type="slidenum">
+            <a:fld id="{345E1F64-5D38-4346-93D8-863CB082BCAF}" type="slidenum">
               <a:rPr lang="ja-JP" smtClean="0"/>
               <a:t>2</a:t>
             </a:fld>
@@ -5523,7 +5523,7 @@
           </a:lstStyle>
           <a:p>
             <a:pPr algn="r"/>
-            <a:fld id="{CC381939-F1FF-4BD0-82A4-EEBB7124B4D6}" type="slidenum">
+            <a:fld id="{847A6711-6FAD-4842-8E84-98035C406AC2}" type="slidenum">
               <a:rPr lang="ja-JP" smtClean="0"/>
               <a:t>2</a:t>
             </a:fld>
@@ -5781,7 +5781,7 @@
           </a:lstStyle>
           <a:p>
             <a:pPr algn="r"/>
-            <a:fld id="{17D72109-B860-4E8C-9464-6E170A2B61D1}" type="slidenum">
+            <a:fld id="{0A048B15-AD0E-4BD2-83A0-30905416309B}" type="slidenum">
               <a:rPr lang="ja-JP" smtClean="0"/>
               <a:t>2</a:t>
             </a:fld>
@@ -6950,7 +6950,7 @@
           </a:lstStyle>
           <a:p>
             <a:pPr algn="r"/>
-            <a:fld id="{D3E8CF82-8448-4E9F-A0DD-A312A9819902}" type="slidenum">
+            <a:fld id="{AC26F570-7423-4908-B11F-C35786808E77}" type="slidenum">
               <a:rPr lang="ja-JP" smtClean="0"/>
               <a:t>2</a:t>
             </a:fld>
@@ -7208,7 +7208,7 @@
           </a:lstStyle>
           <a:p>
             <a:pPr algn="r"/>
-            <a:fld id="{E33455C0-2D4B-42B4-8F87-28CF250D9539}" type="slidenum">
+            <a:fld id="{A5CFED8D-3668-497E-8AD4-0D332D58B766}" type="slidenum">
               <a:rPr lang="ja-JP" smtClean="0"/>
               <a:t>2</a:t>
             </a:fld>
@@ -7470,7 +7470,7 @@
           </a:lstStyle>
           <a:p>
             <a:pPr algn="r"/>
-            <a:fld id="{F6E79F77-0F25-431E-A358-068D1C269CA7}" type="slidenum">
+            <a:fld id="{8A00FC99-ECEC-47ED-B2CB-1D33A91D21F2}" type="slidenum">
               <a:rPr lang="ja-JP" smtClean="0"/>
               <a:t>19</a:t>
             </a:fld>

</xml_diff>

<commit_message>
chore: restore hackathon sample PPTX regenerated by the test run
Co-Authored-By: Claude Opus 5.5 <noreply@anthropic.com>
Claude-Session: https://claude.ai/code/session_01M66qdQfBAyB1eMNb8z4rRo
</commit_message>
<xml_diff>
--- a/hackathon-2026/team-slide-template-kotonara.pptx
+++ b/hackathon-2026/team-slide-template-kotonara.pptx
@@ -3849,7 +3849,7 @@
           </a:lstStyle>
           <a:p>
             <a:pPr algn="r"/>
-            <a:fld id="{9E442E19-F360-4315-BE1F-ABD75DDFD513}" type="slidenum">
+            <a:fld id="{40D8A089-FDE1-42B5-92B3-D3C065A8F993}" type="slidenum">
               <a:rPr lang="ja-JP" smtClean="0"/>
               <a:t>2</a:t>
             </a:fld>
@@ -4096,7 +4096,7 @@
           </a:lstStyle>
           <a:p>
             <a:pPr algn="r"/>
-            <a:fld id="{B2264A87-3A8D-4D11-9D4C-DB76AC793911}" type="slidenum">
+            <a:fld id="{39F7A8FA-FDC9-488F-9AD8-B61132AE6A61}" type="slidenum">
               <a:rPr lang="ja-JP" smtClean="0"/>
               <a:t>2</a:t>
             </a:fld>
@@ -4354,7 +4354,7 @@
           </a:lstStyle>
           <a:p>
             <a:pPr algn="r"/>
-            <a:fld id="{345E1F64-5D38-4346-93D8-863CB082BCAF}" type="slidenum">
+            <a:fld id="{2EFCE54B-6231-45FB-B5F4-AFFD17C749CD}" type="slidenum">
               <a:rPr lang="ja-JP" smtClean="0"/>
               <a:t>2</a:t>
             </a:fld>
@@ -5523,7 +5523,7 @@
           </a:lstStyle>
           <a:p>
             <a:pPr algn="r"/>
-            <a:fld id="{847A6711-6FAD-4842-8E84-98035C406AC2}" type="slidenum">
+            <a:fld id="{CC381939-F1FF-4BD0-82A4-EEBB7124B4D6}" type="slidenum">
               <a:rPr lang="ja-JP" smtClean="0"/>
               <a:t>2</a:t>
             </a:fld>
@@ -5781,7 +5781,7 @@
           </a:lstStyle>
           <a:p>
             <a:pPr algn="r"/>
-            <a:fld id="{0A048B15-AD0E-4BD2-83A0-30905416309B}" type="slidenum">
+            <a:fld id="{17D72109-B860-4E8C-9464-6E170A2B61D1}" type="slidenum">
               <a:rPr lang="ja-JP" smtClean="0"/>
               <a:t>2</a:t>
             </a:fld>
@@ -6950,7 +6950,7 @@
           </a:lstStyle>
           <a:p>
             <a:pPr algn="r"/>
-            <a:fld id="{AC26F570-7423-4908-B11F-C35786808E77}" type="slidenum">
+            <a:fld id="{D3E8CF82-8448-4E9F-A0DD-A312A9819902}" type="slidenum">
               <a:rPr lang="ja-JP" smtClean="0"/>
               <a:t>2</a:t>
             </a:fld>
@@ -7208,7 +7208,7 @@
           </a:lstStyle>
           <a:p>
             <a:pPr algn="r"/>
-            <a:fld id="{A5CFED8D-3668-497E-8AD4-0D332D58B766}" type="slidenum">
+            <a:fld id="{E33455C0-2D4B-42B4-8F87-28CF250D9539}" type="slidenum">
               <a:rPr lang="ja-JP" smtClean="0"/>
               <a:t>2</a:t>
             </a:fld>
@@ -7470,7 +7470,7 @@
           </a:lstStyle>
           <a:p>
             <a:pPr algn="r"/>
-            <a:fld id="{8A00FC99-ECEC-47ED-B2CB-1D33A91D21F2}" type="slidenum">
+            <a:fld id="{F6E79F77-0F25-431E-A358-068D1C269CA7}" type="slidenum">
               <a:rPr lang="ja-JP" smtClean="0"/>
               <a:t>19</a:t>
             </a:fld>

</xml_diff>